<commit_message>
Remove 'no training required' advantage claims
</commit_message>
<xml_diff>
--- a/physcot_project/slides/PhysCoT_slides.pptx
+++ b/physcot_project/slides/PhysCoT_slides.pptx
@@ -5,22 +5,22 @@
     <p:sldMasterId id="2147483648" r:id="rId1"/>
   </p:sldMasterIdLst>
   <p:sldIdLst>
-    <p:sldId id="256" r:id="rId7"/>
-    <p:sldId id="257" r:id="rId8"/>
-    <p:sldId id="258" r:id="rId9"/>
-    <p:sldId id="259" r:id="rId10"/>
-    <p:sldId id="260" r:id="rId11"/>
-    <p:sldId id="261" r:id="rId12"/>
-    <p:sldId id="262" r:id="rId13"/>
-    <p:sldId id="263" r:id="rId14"/>
-    <p:sldId id="264" r:id="rId15"/>
-    <p:sldId id="265" r:id="rId16"/>
-    <p:sldId id="266" r:id="rId17"/>
-    <p:sldId id="267" r:id="rId18"/>
-    <p:sldId id="268" r:id="rId19"/>
-    <p:sldId id="269" r:id="rId20"/>
+    <p:sldId id="256" r:id="rId2"/>
+    <p:sldId id="257" r:id="rId3"/>
+    <p:sldId id="258" r:id="rId4"/>
+    <p:sldId id="259" r:id="rId5"/>
+    <p:sldId id="260" r:id="rId6"/>
+    <p:sldId id="261" r:id="rId7"/>
+    <p:sldId id="262" r:id="rId8"/>
+    <p:sldId id="263" r:id="rId9"/>
+    <p:sldId id="264" r:id="rId10"/>
+    <p:sldId id="265" r:id="rId11"/>
+    <p:sldId id="266" r:id="rId12"/>
+    <p:sldId id="267" r:id="rId13"/>
+    <p:sldId id="268" r:id="rId14"/>
+    <p:sldId id="269" r:id="rId15"/>
   </p:sldIdLst>
-  <p:sldSz cx="12188952" cy="6858000" type="screen4x3"/>
+  <p:sldSz cx="12188825" cy="6858000"/>
   <p:notesSz cx="6858000" cy="9144000"/>
   <p:defaultTextStyle>
     <a:defPPr>
@@ -117,6 +117,22 @@
       </a:defRPr>
     </a:lvl9pPr>
   </p:defaultTextStyle>
+  <p:extLst>
+    <p:ext uri="{EFAFB233-063F-42B5-8137-9DF3F51BA10A}">
+      <p15:sldGuideLst xmlns:p15="http://schemas.microsoft.com/office/powerpoint/2012/main">
+        <p15:guide id="1" orient="horz" pos="2160">
+          <p15:clr>
+            <a:srgbClr val="A4A3A4"/>
+          </p15:clr>
+        </p15:guide>
+        <p15:guide id="2" pos="2880">
+          <p15:clr>
+            <a:srgbClr val="A4A3A4"/>
+          </p15:clr>
+        </p15:guide>
+      </p15:sldGuideLst>
+    </p:ext>
+  </p:extLst>
 </p:presentation>
 </file>
 
@@ -158,10 +174,9 @@
           <a:lstStyle/>
           <a:p>
             <a:r>
-              <a:rPr lang="en-US" smtClean="0"/>
+              <a:rPr lang="en-US"/>
               <a:t>Click to edit Master title style</a:t>
             </a:r>
-            <a:endParaRPr lang="en-US"/>
           </a:p>
         </p:txBody>
       </p:sp>
@@ -277,10 +292,9 @@
           </a:lstStyle>
           <a:p>
             <a:r>
-              <a:rPr lang="en-US" smtClean="0"/>
+              <a:rPr lang="en-US"/>
               <a:t>Click to edit Master subtitle style</a:t>
             </a:r>
-            <a:endParaRPr lang="en-US"/>
           </a:p>
         </p:txBody>
       </p:sp>
@@ -301,7 +315,7 @@
           <a:p>
             <a:fld id="{5BCAD085-E8A6-8845-BD4E-CB4CCA059FC4}" type="datetimeFigureOut">
               <a:rPr lang="en-US" smtClean="0"/>
-              <a:t>1/27/13</a:t>
+              <a:t>3/9/26</a:t>
             </a:fld>
             <a:endParaRPr lang="en-US"/>
           </a:p>
@@ -395,10 +409,9 @@
           <a:lstStyle/>
           <a:p>
             <a:r>
-              <a:rPr lang="en-US" smtClean="0"/>
+              <a:rPr lang="en-US"/>
               <a:t>Click to edit Master title style</a:t>
             </a:r>
-            <a:endParaRPr lang="en-US"/>
           </a:p>
         </p:txBody>
       </p:sp>
@@ -419,38 +432,37 @@
           <a:p>
             <a:pPr lvl="0"/>
             <a:r>
-              <a:rPr lang="en-US" smtClean="0"/>
+              <a:rPr lang="en-US"/>
               <a:t>Click to edit Master text styles</a:t>
             </a:r>
           </a:p>
           <a:p>
             <a:pPr lvl="1"/>
             <a:r>
-              <a:rPr lang="en-US" smtClean="0"/>
+              <a:rPr lang="en-US"/>
               <a:t>Second level</a:t>
             </a:r>
           </a:p>
           <a:p>
             <a:pPr lvl="2"/>
             <a:r>
-              <a:rPr lang="en-US" smtClean="0"/>
+              <a:rPr lang="en-US"/>
               <a:t>Third level</a:t>
             </a:r>
           </a:p>
           <a:p>
             <a:pPr lvl="3"/>
             <a:r>
-              <a:rPr lang="en-US" smtClean="0"/>
+              <a:rPr lang="en-US"/>
               <a:t>Fourth level</a:t>
             </a:r>
           </a:p>
           <a:p>
             <a:pPr lvl="4"/>
             <a:r>
-              <a:rPr lang="en-US" smtClean="0"/>
+              <a:rPr lang="en-US"/>
               <a:t>Fifth level</a:t>
             </a:r>
-            <a:endParaRPr lang="en-US"/>
           </a:p>
         </p:txBody>
       </p:sp>
@@ -471,7 +483,7 @@
           <a:p>
             <a:fld id="{5BCAD085-E8A6-8845-BD4E-CB4CCA059FC4}" type="datetimeFigureOut">
               <a:rPr lang="en-US" smtClean="0"/>
-              <a:t>1/27/13</a:t>
+              <a:t>3/9/26</a:t>
             </a:fld>
             <a:endParaRPr lang="en-US"/>
           </a:p>
@@ -570,10 +582,9 @@
           <a:lstStyle/>
           <a:p>
             <a:r>
-              <a:rPr lang="en-US" smtClean="0"/>
+              <a:rPr lang="en-US"/>
               <a:t>Click to edit Master title style</a:t>
             </a:r>
-            <a:endParaRPr lang="en-US"/>
           </a:p>
         </p:txBody>
       </p:sp>
@@ -599,38 +610,37 @@
           <a:p>
             <a:pPr lvl="0"/>
             <a:r>
-              <a:rPr lang="en-US" smtClean="0"/>
+              <a:rPr lang="en-US"/>
               <a:t>Click to edit Master text styles</a:t>
             </a:r>
           </a:p>
           <a:p>
             <a:pPr lvl="1"/>
             <a:r>
-              <a:rPr lang="en-US" smtClean="0"/>
+              <a:rPr lang="en-US"/>
               <a:t>Second level</a:t>
             </a:r>
           </a:p>
           <a:p>
             <a:pPr lvl="2"/>
             <a:r>
-              <a:rPr lang="en-US" smtClean="0"/>
+              <a:rPr lang="en-US"/>
               <a:t>Third level</a:t>
             </a:r>
           </a:p>
           <a:p>
             <a:pPr lvl="3"/>
             <a:r>
-              <a:rPr lang="en-US" smtClean="0"/>
+              <a:rPr lang="en-US"/>
               <a:t>Fourth level</a:t>
             </a:r>
           </a:p>
           <a:p>
             <a:pPr lvl="4"/>
             <a:r>
-              <a:rPr lang="en-US" smtClean="0"/>
+              <a:rPr lang="en-US"/>
               <a:t>Fifth level</a:t>
             </a:r>
-            <a:endParaRPr lang="en-US"/>
           </a:p>
         </p:txBody>
       </p:sp>
@@ -651,7 +661,7 @@
           <a:p>
             <a:fld id="{5BCAD085-E8A6-8845-BD4E-CB4CCA059FC4}" type="datetimeFigureOut">
               <a:rPr lang="en-US" smtClean="0"/>
-              <a:t>1/27/13</a:t>
+              <a:t>3/9/26</a:t>
             </a:fld>
             <a:endParaRPr lang="en-US"/>
           </a:p>
@@ -745,10 +755,9 @@
           <a:lstStyle/>
           <a:p>
             <a:r>
-              <a:rPr lang="en-US" smtClean="0"/>
+              <a:rPr lang="en-US"/>
               <a:t>Click to edit Master title style</a:t>
             </a:r>
-            <a:endParaRPr lang="en-US"/>
           </a:p>
         </p:txBody>
       </p:sp>
@@ -769,38 +778,37 @@
           <a:p>
             <a:pPr lvl="0"/>
             <a:r>
-              <a:rPr lang="en-US" smtClean="0"/>
+              <a:rPr lang="en-US"/>
               <a:t>Click to edit Master text styles</a:t>
             </a:r>
           </a:p>
           <a:p>
             <a:pPr lvl="1"/>
             <a:r>
-              <a:rPr lang="en-US" smtClean="0"/>
+              <a:rPr lang="en-US"/>
               <a:t>Second level</a:t>
             </a:r>
           </a:p>
           <a:p>
             <a:pPr lvl="2"/>
             <a:r>
-              <a:rPr lang="en-US" smtClean="0"/>
+              <a:rPr lang="en-US"/>
               <a:t>Third level</a:t>
             </a:r>
           </a:p>
           <a:p>
             <a:pPr lvl="3"/>
             <a:r>
-              <a:rPr lang="en-US" smtClean="0"/>
+              <a:rPr lang="en-US"/>
               <a:t>Fourth level</a:t>
             </a:r>
           </a:p>
           <a:p>
             <a:pPr lvl="4"/>
             <a:r>
-              <a:rPr lang="en-US" smtClean="0"/>
+              <a:rPr lang="en-US"/>
               <a:t>Fifth level</a:t>
             </a:r>
-            <a:endParaRPr lang="en-US"/>
           </a:p>
         </p:txBody>
       </p:sp>
@@ -821,7 +829,7 @@
           <a:p>
             <a:fld id="{5BCAD085-E8A6-8845-BD4E-CB4CCA059FC4}" type="datetimeFigureOut">
               <a:rPr lang="en-US" smtClean="0"/>
-              <a:t>1/27/13</a:t>
+              <a:t>3/9/26</a:t>
             </a:fld>
             <a:endParaRPr lang="en-US"/>
           </a:p>
@@ -924,10 +932,9 @@
           </a:lstStyle>
           <a:p>
             <a:r>
-              <a:rPr lang="en-US" smtClean="0"/>
+              <a:rPr lang="en-US"/>
               <a:t>Click to edit Master title style</a:t>
             </a:r>
-            <a:endParaRPr lang="en-US"/>
           </a:p>
         </p:txBody>
       </p:sp>
@@ -1044,7 +1051,7 @@
           <a:p>
             <a:pPr lvl="0"/>
             <a:r>
-              <a:rPr lang="en-US" smtClean="0"/>
+              <a:rPr lang="en-US"/>
               <a:t>Click to edit Master text styles</a:t>
             </a:r>
           </a:p>
@@ -1067,7 +1074,7 @@
           <a:p>
             <a:fld id="{5BCAD085-E8A6-8845-BD4E-CB4CCA059FC4}" type="datetimeFigureOut">
               <a:rPr lang="en-US" smtClean="0"/>
-              <a:t>1/27/13</a:t>
+              <a:t>3/9/26</a:t>
             </a:fld>
             <a:endParaRPr lang="en-US"/>
           </a:p>
@@ -1161,10 +1168,9 @@
           <a:lstStyle/>
           <a:p>
             <a:r>
-              <a:rPr lang="en-US" smtClean="0"/>
+              <a:rPr lang="en-US"/>
               <a:t>Click to edit Master title style</a:t>
             </a:r>
-            <a:endParaRPr lang="en-US"/>
           </a:p>
         </p:txBody>
       </p:sp>
@@ -1218,38 +1224,37 @@
           <a:p>
             <a:pPr lvl="0"/>
             <a:r>
-              <a:rPr lang="en-US" smtClean="0"/>
+              <a:rPr lang="en-US"/>
               <a:t>Click to edit Master text styles</a:t>
             </a:r>
           </a:p>
           <a:p>
             <a:pPr lvl="1"/>
             <a:r>
-              <a:rPr lang="en-US" smtClean="0"/>
+              <a:rPr lang="en-US"/>
               <a:t>Second level</a:t>
             </a:r>
           </a:p>
           <a:p>
             <a:pPr lvl="2"/>
             <a:r>
-              <a:rPr lang="en-US" smtClean="0"/>
+              <a:rPr lang="en-US"/>
               <a:t>Third level</a:t>
             </a:r>
           </a:p>
           <a:p>
             <a:pPr lvl="3"/>
             <a:r>
-              <a:rPr lang="en-US" smtClean="0"/>
+              <a:rPr lang="en-US"/>
               <a:t>Fourth level</a:t>
             </a:r>
           </a:p>
           <a:p>
             <a:pPr lvl="4"/>
             <a:r>
-              <a:rPr lang="en-US" smtClean="0"/>
+              <a:rPr lang="en-US"/>
               <a:t>Fifth level</a:t>
             </a:r>
-            <a:endParaRPr lang="en-US"/>
           </a:p>
         </p:txBody>
       </p:sp>
@@ -1303,38 +1308,37 @@
           <a:p>
             <a:pPr lvl="0"/>
             <a:r>
-              <a:rPr lang="en-US" smtClean="0"/>
+              <a:rPr lang="en-US"/>
               <a:t>Click to edit Master text styles</a:t>
             </a:r>
           </a:p>
           <a:p>
             <a:pPr lvl="1"/>
             <a:r>
-              <a:rPr lang="en-US" smtClean="0"/>
+              <a:rPr lang="en-US"/>
               <a:t>Second level</a:t>
             </a:r>
           </a:p>
           <a:p>
             <a:pPr lvl="2"/>
             <a:r>
-              <a:rPr lang="en-US" smtClean="0"/>
+              <a:rPr lang="en-US"/>
               <a:t>Third level</a:t>
             </a:r>
           </a:p>
           <a:p>
             <a:pPr lvl="3"/>
             <a:r>
-              <a:rPr lang="en-US" smtClean="0"/>
+              <a:rPr lang="en-US"/>
               <a:t>Fourth level</a:t>
             </a:r>
           </a:p>
           <a:p>
             <a:pPr lvl="4"/>
             <a:r>
-              <a:rPr lang="en-US" smtClean="0"/>
+              <a:rPr lang="en-US"/>
               <a:t>Fifth level</a:t>
             </a:r>
-            <a:endParaRPr lang="en-US"/>
           </a:p>
         </p:txBody>
       </p:sp>
@@ -1355,7 +1359,7 @@
           <a:p>
             <a:fld id="{5BCAD085-E8A6-8845-BD4E-CB4CCA059FC4}" type="datetimeFigureOut">
               <a:rPr lang="en-US" smtClean="0"/>
-              <a:t>1/27/13</a:t>
+              <a:t>3/9/26</a:t>
             </a:fld>
             <a:endParaRPr lang="en-US"/>
           </a:p>
@@ -1453,10 +1457,9 @@
           </a:lstStyle>
           <a:p>
             <a:r>
-              <a:rPr lang="en-US" smtClean="0"/>
+              <a:rPr lang="en-US"/>
               <a:t>Click to edit Master title style</a:t>
             </a:r>
-            <a:endParaRPr lang="en-US"/>
           </a:p>
         </p:txBody>
       </p:sp>
@@ -1519,7 +1522,7 @@
           <a:p>
             <a:pPr lvl="0"/>
             <a:r>
-              <a:rPr lang="en-US" smtClean="0"/>
+              <a:rPr lang="en-US"/>
               <a:t>Click to edit Master text styles</a:t>
             </a:r>
           </a:p>
@@ -1575,38 +1578,37 @@
           <a:p>
             <a:pPr lvl="0"/>
             <a:r>
-              <a:rPr lang="en-US" smtClean="0"/>
+              <a:rPr lang="en-US"/>
               <a:t>Click to edit Master text styles</a:t>
             </a:r>
           </a:p>
           <a:p>
             <a:pPr lvl="1"/>
             <a:r>
-              <a:rPr lang="en-US" smtClean="0"/>
+              <a:rPr lang="en-US"/>
               <a:t>Second level</a:t>
             </a:r>
           </a:p>
           <a:p>
             <a:pPr lvl="2"/>
             <a:r>
-              <a:rPr lang="en-US" smtClean="0"/>
+              <a:rPr lang="en-US"/>
               <a:t>Third level</a:t>
             </a:r>
           </a:p>
           <a:p>
             <a:pPr lvl="3"/>
             <a:r>
-              <a:rPr lang="en-US" smtClean="0"/>
+              <a:rPr lang="en-US"/>
               <a:t>Fourth level</a:t>
             </a:r>
           </a:p>
           <a:p>
             <a:pPr lvl="4"/>
             <a:r>
-              <a:rPr lang="en-US" smtClean="0"/>
+              <a:rPr lang="en-US"/>
               <a:t>Fifth level</a:t>
             </a:r>
-            <a:endParaRPr lang="en-US"/>
           </a:p>
         </p:txBody>
       </p:sp>
@@ -1669,7 +1671,7 @@
           <a:p>
             <a:pPr lvl="0"/>
             <a:r>
-              <a:rPr lang="en-US" smtClean="0"/>
+              <a:rPr lang="en-US"/>
               <a:t>Click to edit Master text styles</a:t>
             </a:r>
           </a:p>
@@ -1725,38 +1727,37 @@
           <a:p>
             <a:pPr lvl="0"/>
             <a:r>
-              <a:rPr lang="en-US" smtClean="0"/>
+              <a:rPr lang="en-US"/>
               <a:t>Click to edit Master text styles</a:t>
             </a:r>
           </a:p>
           <a:p>
             <a:pPr lvl="1"/>
             <a:r>
-              <a:rPr lang="en-US" smtClean="0"/>
+              <a:rPr lang="en-US"/>
               <a:t>Second level</a:t>
             </a:r>
           </a:p>
           <a:p>
             <a:pPr lvl="2"/>
             <a:r>
-              <a:rPr lang="en-US" smtClean="0"/>
+              <a:rPr lang="en-US"/>
               <a:t>Third level</a:t>
             </a:r>
           </a:p>
           <a:p>
             <a:pPr lvl="3"/>
             <a:r>
-              <a:rPr lang="en-US" smtClean="0"/>
+              <a:rPr lang="en-US"/>
               <a:t>Fourth level</a:t>
             </a:r>
           </a:p>
           <a:p>
             <a:pPr lvl="4"/>
             <a:r>
-              <a:rPr lang="en-US" smtClean="0"/>
+              <a:rPr lang="en-US"/>
               <a:t>Fifth level</a:t>
             </a:r>
-            <a:endParaRPr lang="en-US"/>
           </a:p>
         </p:txBody>
       </p:sp>
@@ -1777,7 +1778,7 @@
           <a:p>
             <a:fld id="{5BCAD085-E8A6-8845-BD4E-CB4CCA059FC4}" type="datetimeFigureOut">
               <a:rPr lang="en-US" smtClean="0"/>
-              <a:t>1/27/13</a:t>
+              <a:t>3/9/26</a:t>
             </a:fld>
             <a:endParaRPr lang="en-US"/>
           </a:p>
@@ -1871,10 +1872,9 @@
           <a:lstStyle/>
           <a:p>
             <a:r>
-              <a:rPr lang="en-US" smtClean="0"/>
+              <a:rPr lang="en-US"/>
               <a:t>Click to edit Master title style</a:t>
             </a:r>
-            <a:endParaRPr lang="en-US"/>
           </a:p>
         </p:txBody>
       </p:sp>
@@ -1895,7 +1895,7 @@
           <a:p>
             <a:fld id="{5BCAD085-E8A6-8845-BD4E-CB4CCA059FC4}" type="datetimeFigureOut">
               <a:rPr lang="en-US" smtClean="0"/>
-              <a:t>1/27/13</a:t>
+              <a:t>3/9/26</a:t>
             </a:fld>
             <a:endParaRPr lang="en-US"/>
           </a:p>
@@ -1990,7 +1990,7 @@
           <a:p>
             <a:fld id="{5BCAD085-E8A6-8845-BD4E-CB4CCA059FC4}" type="datetimeFigureOut">
               <a:rPr lang="en-US" smtClean="0"/>
-              <a:t>1/27/13</a:t>
+              <a:t>3/9/26</a:t>
             </a:fld>
             <a:endParaRPr lang="en-US"/>
           </a:p>
@@ -2093,10 +2093,9 @@
           </a:lstStyle>
           <a:p>
             <a:r>
-              <a:rPr lang="en-US" smtClean="0"/>
+              <a:rPr lang="en-US"/>
               <a:t>Click to edit Master title style</a:t>
             </a:r>
-            <a:endParaRPr lang="en-US"/>
           </a:p>
         </p:txBody>
       </p:sp>
@@ -2150,38 +2149,37 @@
           <a:p>
             <a:pPr lvl="0"/>
             <a:r>
-              <a:rPr lang="en-US" smtClean="0"/>
+              <a:rPr lang="en-US"/>
               <a:t>Click to edit Master text styles</a:t>
             </a:r>
           </a:p>
           <a:p>
             <a:pPr lvl="1"/>
             <a:r>
-              <a:rPr lang="en-US" smtClean="0"/>
+              <a:rPr lang="en-US"/>
               <a:t>Second level</a:t>
             </a:r>
           </a:p>
           <a:p>
             <a:pPr lvl="2"/>
             <a:r>
-              <a:rPr lang="en-US" smtClean="0"/>
+              <a:rPr lang="en-US"/>
               <a:t>Third level</a:t>
             </a:r>
           </a:p>
           <a:p>
             <a:pPr lvl="3"/>
             <a:r>
-              <a:rPr lang="en-US" smtClean="0"/>
+              <a:rPr lang="en-US"/>
               <a:t>Fourth level</a:t>
             </a:r>
           </a:p>
           <a:p>
             <a:pPr lvl="4"/>
             <a:r>
-              <a:rPr lang="en-US" smtClean="0"/>
+              <a:rPr lang="en-US"/>
               <a:t>Fifth level</a:t>
             </a:r>
-            <a:endParaRPr lang="en-US"/>
           </a:p>
         </p:txBody>
       </p:sp>
@@ -2244,7 +2242,7 @@
           <a:p>
             <a:pPr lvl="0"/>
             <a:r>
-              <a:rPr lang="en-US" smtClean="0"/>
+              <a:rPr lang="en-US"/>
               <a:t>Click to edit Master text styles</a:t>
             </a:r>
           </a:p>
@@ -2267,7 +2265,7 @@
           <a:p>
             <a:fld id="{5BCAD085-E8A6-8845-BD4E-CB4CCA059FC4}" type="datetimeFigureOut">
               <a:rPr lang="en-US" smtClean="0"/>
-              <a:t>1/27/13</a:t>
+              <a:t>3/9/26</a:t>
             </a:fld>
             <a:endParaRPr lang="en-US"/>
           </a:p>
@@ -2370,10 +2368,9 @@
           </a:lstStyle>
           <a:p>
             <a:r>
-              <a:rPr lang="en-US" smtClean="0"/>
+              <a:rPr lang="en-US"/>
               <a:t>Click to edit Master title style</a:t>
             </a:r>
-            <a:endParaRPr lang="en-US"/>
           </a:p>
         </p:txBody>
       </p:sp>
@@ -2497,7 +2494,7 @@
           <a:p>
             <a:pPr lvl="0"/>
             <a:r>
-              <a:rPr lang="en-US" smtClean="0"/>
+              <a:rPr lang="en-US"/>
               <a:t>Click to edit Master text styles</a:t>
             </a:r>
           </a:p>
@@ -2520,7 +2517,7 @@
           <a:p>
             <a:fld id="{5BCAD085-E8A6-8845-BD4E-CB4CCA059FC4}" type="datetimeFigureOut">
               <a:rPr lang="en-US" smtClean="0"/>
-              <a:t>1/27/13</a:t>
+              <a:t>3/9/26</a:t>
             </a:fld>
             <a:endParaRPr lang="en-US"/>
           </a:p>
@@ -2629,10 +2626,9 @@
           <a:lstStyle/>
           <a:p>
             <a:r>
-              <a:rPr lang="en-US" smtClean="0"/>
+              <a:rPr lang="en-US"/>
               <a:t>Click to edit Master title style</a:t>
             </a:r>
-            <a:endParaRPr lang="en-US"/>
           </a:p>
         </p:txBody>
       </p:sp>
@@ -2663,38 +2659,37 @@
           <a:p>
             <a:pPr lvl="0"/>
             <a:r>
-              <a:rPr lang="en-US" smtClean="0"/>
+              <a:rPr lang="en-US"/>
               <a:t>Click to edit Master text styles</a:t>
             </a:r>
           </a:p>
           <a:p>
             <a:pPr lvl="1"/>
             <a:r>
-              <a:rPr lang="en-US" smtClean="0"/>
+              <a:rPr lang="en-US"/>
               <a:t>Second level</a:t>
             </a:r>
           </a:p>
           <a:p>
             <a:pPr lvl="2"/>
             <a:r>
-              <a:rPr lang="en-US" smtClean="0"/>
+              <a:rPr lang="en-US"/>
               <a:t>Third level</a:t>
             </a:r>
           </a:p>
           <a:p>
             <a:pPr lvl="3"/>
             <a:r>
-              <a:rPr lang="en-US" smtClean="0"/>
+              <a:rPr lang="en-US"/>
               <a:t>Fourth level</a:t>
             </a:r>
           </a:p>
           <a:p>
             <a:pPr lvl="4"/>
             <a:r>
-              <a:rPr lang="en-US" smtClean="0"/>
+              <a:rPr lang="en-US"/>
               <a:t>Fifth level</a:t>
             </a:r>
-            <a:endParaRPr lang="en-US"/>
           </a:p>
         </p:txBody>
       </p:sp>
@@ -2733,7 +2728,7 @@
           <a:p>
             <a:fld id="{5BCAD085-E8A6-8845-BD4E-CB4CCA059FC4}" type="datetimeFigureOut">
               <a:rPr lang="en-US" smtClean="0"/>
-              <a:t>1/27/13</a:t>
+              <a:t>3/9/26</a:t>
             </a:fld>
             <a:endParaRPr lang="en-US"/>
           </a:p>
@@ -3092,7 +3087,7 @@
 </file>
 
 <file path=ppt/slides/slide1.xml><?xml version="1.0" encoding="utf-8"?>
-<p:sld xmlns:a="http://schemas.openxmlformats.org/drawingml/2006/main" xmlns:p="http://schemas.openxmlformats.org/presentationml/2006/main" xmlns:r="http://schemas.openxmlformats.org/officeDocument/2006/relationships">
+<p:sld xmlns:a="http://schemas.openxmlformats.org/drawingml/2006/main" xmlns:r="http://schemas.openxmlformats.org/officeDocument/2006/relationships" xmlns:p="http://schemas.openxmlformats.org/presentationml/2006/main">
   <p:cSld>
     <p:bg>
       <p:bgPr>
@@ -3108,7 +3103,14 @@
         <p:cNvGrpSpPr/>
         <p:nvPr/>
       </p:nvGrpSpPr>
-      <p:grpSpPr/>
+      <p:grpSpPr>
+        <a:xfrm>
+          <a:off x="0" y="0"/>
+          <a:ext cx="0" cy="0"/>
+          <a:chOff x="0" y="0"/>
+          <a:chExt cx="0" cy="0"/>
+        </a:xfrm>
+      </p:grpSpPr>
       <p:sp>
         <p:nvSpPr>
           <p:cNvPr id="2" name="Rectangle 1"/>
@@ -3149,6 +3151,7 @@
           <a:lstStyle/>
           <a:p>
             <a:pPr algn="ctr"/>
+            <a:endParaRPr/>
           </a:p>
         </p:txBody>
       </p:sp>
@@ -3332,6 +3335,7 @@
           <a:lstStyle/>
           <a:p>
             <a:pPr algn="ctr"/>
+            <a:endParaRPr/>
           </a:p>
         </p:txBody>
       </p:sp>
@@ -3411,6 +3415,7 @@
           <a:lstStyle/>
           <a:p>
             <a:pPr algn="ctr"/>
+            <a:endParaRPr/>
           </a:p>
         </p:txBody>
       </p:sp>
@@ -3489,6 +3494,7 @@
           <a:lstStyle/>
           <a:p>
             <a:pPr algn="ctr"/>
+            <a:endParaRPr/>
           </a:p>
         </p:txBody>
       </p:sp>
@@ -3550,15 +3556,7 @@
           <a:lstStyle/>
           <a:p>
             <a:pPr algn="ctr"/>
-            <a:r>
-              <a:rPr sz="1200" b="0" i="1">
-                <a:solidFill>
-                  <a:srgbClr val="2980B9"/>
-                </a:solidFill>
-                <a:latin typeface="Calibri"/>
-              </a:rPr>
-              <a:t/>
-            </a:r>
+            <a:endParaRPr/>
           </a:p>
         </p:txBody>
       </p:sp>
@@ -3602,6 +3600,7 @@
           <a:lstStyle/>
           <a:p>
             <a:pPr algn="ctr"/>
+            <a:endParaRPr/>
           </a:p>
         </p:txBody>
       </p:sp>
@@ -3684,7 +3683,7 @@
 </file>
 
 <file path=ppt/slides/slide10.xml><?xml version="1.0" encoding="utf-8"?>
-<p:sld xmlns:a="http://schemas.openxmlformats.org/drawingml/2006/main" xmlns:p="http://schemas.openxmlformats.org/presentationml/2006/main" xmlns:r="http://schemas.openxmlformats.org/officeDocument/2006/relationships">
+<p:sld xmlns:a="http://schemas.openxmlformats.org/drawingml/2006/main" xmlns:r="http://schemas.openxmlformats.org/officeDocument/2006/relationships" xmlns:p="http://schemas.openxmlformats.org/presentationml/2006/main">
   <p:cSld>
     <p:bg>
       <p:bgPr>
@@ -3700,7 +3699,14 @@
         <p:cNvGrpSpPr/>
         <p:nvPr/>
       </p:nvGrpSpPr>
-      <p:grpSpPr/>
+      <p:grpSpPr>
+        <a:xfrm>
+          <a:off x="0" y="0"/>
+          <a:ext cx="0" cy="0"/>
+          <a:chOff x="0" y="0"/>
+          <a:chExt cx="0" cy="0"/>
+        </a:xfrm>
+      </p:grpSpPr>
       <p:sp>
         <p:nvSpPr>
           <p:cNvPr id="2" name="Rectangle 1"/>
@@ -3741,6 +3747,7 @@
           <a:lstStyle/>
           <a:p>
             <a:pPr algn="ctr"/>
+            <a:endParaRPr/>
           </a:p>
         </p:txBody>
       </p:sp>
@@ -3827,7 +3834,7 @@
           <a:p>
             <a:pPr algn="l"/>
             <a:r>
-              <a:rPr sz="1500" b="1" i="0">
+              <a:rPr sz="1500" b="1" i="0" dirty="0">
                 <a:solidFill>
                   <a:srgbClr val="2C3E50"/>
                 </a:solidFill>
@@ -4055,6 +4062,7 @@
           <a:lstStyle/>
           <a:p>
             <a:pPr algn="ctr"/>
+            <a:endParaRPr/>
           </a:p>
         </p:txBody>
       </p:sp>
@@ -4134,6 +4142,7 @@
           <a:lstStyle/>
           <a:p>
             <a:pPr algn="ctr"/>
+            <a:endParaRPr/>
           </a:p>
         </p:txBody>
       </p:sp>
@@ -4216,7 +4225,7 @@
 </file>
 
 <file path=ppt/slides/slide11.xml><?xml version="1.0" encoding="utf-8"?>
-<p:sld xmlns:a="http://schemas.openxmlformats.org/drawingml/2006/main" xmlns:p="http://schemas.openxmlformats.org/presentationml/2006/main" xmlns:r="http://schemas.openxmlformats.org/officeDocument/2006/relationships">
+<p:sld xmlns:a="http://schemas.openxmlformats.org/drawingml/2006/main" xmlns:r="http://schemas.openxmlformats.org/officeDocument/2006/relationships" xmlns:p="http://schemas.openxmlformats.org/presentationml/2006/main">
   <p:cSld>
     <p:bg>
       <p:bgPr>
@@ -4232,7 +4241,14 @@
         <p:cNvGrpSpPr/>
         <p:nvPr/>
       </p:nvGrpSpPr>
-      <p:grpSpPr/>
+      <p:grpSpPr>
+        <a:xfrm>
+          <a:off x="0" y="0"/>
+          <a:ext cx="0" cy="0"/>
+          <a:chOff x="0" y="0"/>
+          <a:chExt cx="0" cy="0"/>
+        </a:xfrm>
+      </p:grpSpPr>
       <p:sp>
         <p:nvSpPr>
           <p:cNvPr id="2" name="Rectangle 1"/>
@@ -4273,6 +4289,7 @@
           <a:lstStyle/>
           <a:p>
             <a:pPr algn="ctr"/>
+            <a:endParaRPr/>
           </a:p>
         </p:txBody>
       </p:sp>
@@ -4320,7 +4337,7 @@
         <p:spPr>
           <a:xfrm>
             <a:off x="457200" y="1234440"/>
-            <a:ext cx="11274552" cy="411480"/>
+            <a:ext cx="11274552" cy="323165"/>
           </a:xfrm>
           <a:prstGeom prst="rect">
             <a:avLst/>
@@ -4335,14 +4352,38 @@
           <a:p>
             <a:pPr algn="ctr"/>
             <a:r>
-              <a:rPr sz="1500" b="0" i="1">
+              <a:rPr lang="en-US" sz="1500" i="1" dirty="0">
                 <a:solidFill>
                   <a:srgbClr val="95A5A6"/>
                 </a:solidFill>
                 <a:latin typeface="Calibri"/>
               </a:rPr>
-              <a:t>All 40 trial videos in results/videos/ in the project repository</a:t>
-            </a:r>
+              <a:t>V</a:t>
+            </a:r>
+            <a:r>
+              <a:rPr sz="1500" b="0" i="1" dirty="0">
+                <a:solidFill>
+                  <a:srgbClr val="95A5A6"/>
+                </a:solidFill>
+                <a:latin typeface="Calibri"/>
+              </a:rPr>
+              <a:t>ideo</a:t>
+            </a:r>
+            <a:r>
+              <a:rPr lang="en-US" sz="1500" b="0" i="1" dirty="0">
+                <a:solidFill>
+                  <a:srgbClr val="95A5A6"/>
+                </a:solidFill>
+                <a:latin typeface="Calibri"/>
+              </a:rPr>
+              <a:t> Demo</a:t>
+            </a:r>
+            <a:endParaRPr sz="1500" b="0" i="1" dirty="0">
+              <a:solidFill>
+                <a:srgbClr val="95A5A6"/>
+              </a:solidFill>
+              <a:latin typeface="Calibri"/>
+            </a:endParaRPr>
           </a:p>
         </p:txBody>
       </p:sp>
@@ -4355,7 +4396,7 @@
         <p:spPr>
           <a:xfrm>
             <a:off x="365760" y="1828800"/>
-            <a:ext cx="5394960" cy="3200400"/>
+            <a:ext cx="5394960" cy="1953491"/>
           </a:xfrm>
           <a:prstGeom prst="rect">
             <a:avLst/>
@@ -4386,6 +4427,7 @@
           <a:lstStyle/>
           <a:p>
             <a:pPr algn="ctr"/>
+            <a:endParaRPr/>
           </a:p>
         </p:txBody>
       </p:sp>
@@ -4413,7 +4455,7 @@
           <a:p>
             <a:pPr algn="l"/>
             <a:r>
-              <a:rPr sz="1100" b="1" i="0">
+              <a:rPr sz="1100" b="1" i="0" dirty="0">
                 <a:solidFill>
                   <a:srgbClr val="FFFFFF"/>
                 </a:solidFill>
@@ -4433,7 +4475,7 @@
         <p:spPr>
           <a:xfrm>
             <a:off x="457200" y="2176272"/>
-            <a:ext cx="5212080" cy="2798064"/>
+            <a:ext cx="5212080" cy="1092607"/>
           </a:xfrm>
           <a:prstGeom prst="rect">
             <a:avLst/>
@@ -4448,18 +4490,34 @@
           <a:p>
             <a:pPr algn="l"/>
             <a:r>
-              <a:rPr sz="1300" b="0" i="0">
+              <a:rPr sz="1300" b="0" i="0" dirty="0">
                 <a:solidFill>
                   <a:srgbClr val="FFFFFF"/>
                 </a:solidFill>
                 <a:latin typeface="Calibri"/>
               </a:rPr>
               <a:t>Baseline Trial 5 (FAIL):
-results/videos/exp1_block_toppling/baseline/trial_04.mp4
 ⇒ Contact at 32% height → sliding, no topple
-PhysCoT Trial 5 (SUCCESS):
-results/videos/exp1_block_toppling/physcot/trial_04.mp4
-⇒ Contact at 69% height → clean topple</a:t>
+</a:t>
+            </a:r>
+            <a:r>
+              <a:rPr sz="1300" b="0" i="0" dirty="0" err="1">
+                <a:solidFill>
+                  <a:srgbClr val="FFFFFF"/>
+                </a:solidFill>
+                <a:latin typeface="Calibri"/>
+              </a:rPr>
+              <a:t>PhysCoT</a:t>
+            </a:r>
+            <a:r>
+              <a:rPr sz="1300" b="0" i="0" dirty="0">
+                <a:solidFill>
+                  <a:srgbClr val="FFFFFF"/>
+                </a:solidFill>
+                <a:latin typeface="Calibri"/>
+              </a:rPr>
+              <a:t> Trial 5 (SUCCESS):
+</a:t>
             </a:r>
           </a:p>
         </p:txBody>
@@ -4473,7 +4531,7 @@
         <p:spPr>
           <a:xfrm>
             <a:off x="6126480" y="1828800"/>
-            <a:ext cx="5669280" cy="3200400"/>
+            <a:ext cx="5669280" cy="1932709"/>
           </a:xfrm>
           <a:prstGeom prst="rect">
             <a:avLst/>
@@ -4504,6 +4562,7 @@
           <a:lstStyle/>
           <a:p>
             <a:pPr algn="ctr"/>
+            <a:endParaRPr/>
           </a:p>
         </p:txBody>
       </p:sp>
@@ -4551,7 +4610,7 @@
         <p:spPr>
           <a:xfrm>
             <a:off x="6217920" y="2176272"/>
-            <a:ext cx="5486400" cy="2798064"/>
+            <a:ext cx="5486400" cy="1092607"/>
           </a:xfrm>
           <a:prstGeom prst="rect">
             <a:avLst/>
@@ -4566,53 +4625,34 @@
           <a:p>
             <a:pPr algn="l"/>
             <a:r>
-              <a:rPr sz="1300" b="0" i="0">
+              <a:rPr sz="1300" b="0" i="0" dirty="0">
                 <a:solidFill>
                   <a:srgbClr val="FFFFFF"/>
                 </a:solidFill>
                 <a:latin typeface="Calibri"/>
               </a:rPr>
               <a:t>Baseline Trial 2 (FAIL):
-results/videos/exp2_tool_selection/baseline/trial_01.mp4
 ⇒ Straight tool → path blocked, object stuck
-PhysCoT Trial 1 (SUCCESS):
-results/videos/exp2_tool_selection/physcot/trial_00.mp4
+</a:t>
+            </a:r>
+            <a:r>
+              <a:rPr sz="1300" b="0" i="0" dirty="0" err="1">
+                <a:solidFill>
+                  <a:srgbClr val="FFFFFF"/>
+                </a:solidFill>
+                <a:latin typeface="Calibri"/>
+              </a:rPr>
+              <a:t>PhysCoT</a:t>
+            </a:r>
+            <a:r>
+              <a:rPr sz="1300" b="0" i="0" dirty="0">
+                <a:solidFill>
+                  <a:srgbClr val="FFFFFF"/>
+                </a:solidFill>
+                <a:latin typeface="Calibri"/>
+              </a:rPr>
+              <a:t> Trial 1 (SUCCESS):
 ⇒ Hook tool → arc path → object at goal</a:t>
-            </a:r>
-          </a:p>
-        </p:txBody>
-      </p:sp>
-      <p:sp>
-        <p:nvSpPr>
-          <p:cNvPr id="11" name="TextBox 10"/>
-          <p:cNvSpPr txBox="1"/>
-          <p:nvPr/>
-        </p:nvSpPr>
-        <p:spPr>
-          <a:xfrm>
-            <a:off x="457200" y="5486400"/>
-            <a:ext cx="11274552" cy="548640"/>
-          </a:xfrm>
-          <a:prstGeom prst="rect">
-            <a:avLst/>
-          </a:prstGeom>
-          <a:noFill/>
-        </p:spPr>
-        <p:txBody>
-          <a:bodyPr wrap="square">
-            <a:spAutoFit/>
-          </a:bodyPr>
-          <a:lstStyle/>
-          <a:p>
-            <a:pPr algn="ctr"/>
-            <a:r>
-              <a:rPr sz="1500" b="1" i="0">
-                <a:solidFill>
-                  <a:srgbClr val="8C1515"/>
-                </a:solidFill>
-                <a:latin typeface="Calibri"/>
-              </a:rPr>
-              <a:t>▶ Open MP4 files with any video player to review rollout behavior</a:t>
             </a:r>
           </a:p>
         </p:txBody>
@@ -4657,6 +4697,7 @@
           <a:lstStyle/>
           <a:p>
             <a:pPr algn="ctr"/>
+            <a:endParaRPr/>
           </a:p>
         </p:txBody>
       </p:sp>
@@ -4727,6 +4768,169 @@
               </a:rPr>
               <a:t>11 / 14</a:t>
             </a:r>
+          </a:p>
+        </p:txBody>
+      </p:sp>
+      <p:pic>
+        <p:nvPicPr>
+          <p:cNvPr id="16" name="Picture 15" descr="A robot arm holding a red box&#10;&#10;AI-generated content may be incorrect.">
+            <a:extLst>
+              <a:ext uri="{FF2B5EF4-FFF2-40B4-BE49-F238E27FC236}">
+                <a16:creationId xmlns:a16="http://schemas.microsoft.com/office/drawing/2014/main" id="{2C8D951F-9879-77C3-EFF1-3658989D9834}"/>
+              </a:ext>
+            </a:extLst>
+          </p:cNvPr>
+          <p:cNvPicPr>
+            <a:picLocks noChangeAspect="1"/>
+          </p:cNvPicPr>
+          <p:nvPr/>
+        </p:nvPicPr>
+        <p:blipFill>
+          <a:blip r:embed="rId2"/>
+          <a:stretch>
+            <a:fillRect/>
+          </a:stretch>
+        </p:blipFill>
+        <p:spPr>
+          <a:xfrm>
+            <a:off x="2083950" y="3965171"/>
+            <a:ext cx="2139545" cy="2139545"/>
+          </a:xfrm>
+          <a:prstGeom prst="rect">
+            <a:avLst/>
+          </a:prstGeom>
+        </p:spPr>
+      </p:pic>
+      <p:sp>
+        <p:nvSpPr>
+          <p:cNvPr id="20" name="TextBox 19">
+            <a:extLst>
+              <a:ext uri="{FF2B5EF4-FFF2-40B4-BE49-F238E27FC236}">
+                <a16:creationId xmlns:a16="http://schemas.microsoft.com/office/drawing/2014/main" id="{1A3D9657-2DD1-6A9D-98B7-3ED81EDA614A}"/>
+              </a:ext>
+            </a:extLst>
+          </p:cNvPr>
+          <p:cNvSpPr txBox="1"/>
+          <p:nvPr/>
+        </p:nvSpPr>
+        <p:spPr>
+          <a:xfrm>
+            <a:off x="2751513" y="6135625"/>
+            <a:ext cx="1307869" cy="320041"/>
+          </a:xfrm>
+          <a:prstGeom prst="rect">
+            <a:avLst/>
+          </a:prstGeom>
+          <a:noFill/>
+        </p:spPr>
+        <p:txBody>
+          <a:bodyPr wrap="square">
+            <a:spAutoFit/>
+          </a:bodyPr>
+          <a:lstStyle/>
+          <a:p>
+            <a:pPr algn="l"/>
+            <a:r>
+              <a:rPr lang="en-US" sz="1500" b="1" i="0" dirty="0">
+                <a:solidFill>
+                  <a:srgbClr val="2C3E50"/>
+                </a:solidFill>
+                <a:latin typeface="Calibri"/>
+              </a:rPr>
+              <a:t>Phys-</a:t>
+            </a:r>
+            <a:r>
+              <a:rPr lang="en-US" sz="1500" b="1" i="0" dirty="0" err="1">
+                <a:solidFill>
+                  <a:srgbClr val="2C3E50"/>
+                </a:solidFill>
+                <a:latin typeface="Calibri"/>
+              </a:rPr>
+              <a:t>CoT</a:t>
+            </a:r>
+            <a:endParaRPr sz="1500" b="1" i="0" dirty="0">
+              <a:solidFill>
+                <a:srgbClr val="2C3E50"/>
+              </a:solidFill>
+              <a:latin typeface="Calibri"/>
+            </a:endParaRPr>
+          </a:p>
+        </p:txBody>
+      </p:sp>
+      <p:pic>
+        <p:nvPicPr>
+          <p:cNvPr id="26" name="Picture 25" descr="A robot arm on a table&#10;&#10;AI-generated content may be incorrect.">
+            <a:extLst>
+              <a:ext uri="{FF2B5EF4-FFF2-40B4-BE49-F238E27FC236}">
+                <a16:creationId xmlns:a16="http://schemas.microsoft.com/office/drawing/2014/main" id="{1CD14E6E-5C72-5751-ED77-D7FD15B37F24}"/>
+              </a:ext>
+            </a:extLst>
+          </p:cNvPr>
+          <p:cNvPicPr>
+            <a:picLocks noChangeAspect="1"/>
+          </p:cNvPicPr>
+          <p:nvPr/>
+        </p:nvPicPr>
+        <p:blipFill>
+          <a:blip r:embed="rId3"/>
+          <a:stretch>
+            <a:fillRect/>
+          </a:stretch>
+        </p:blipFill>
+        <p:spPr>
+          <a:xfrm>
+            <a:off x="7498458" y="3926402"/>
+            <a:ext cx="2139545" cy="2139545"/>
+          </a:xfrm>
+          <a:prstGeom prst="rect">
+            <a:avLst/>
+          </a:prstGeom>
+        </p:spPr>
+      </p:pic>
+      <p:sp>
+        <p:nvSpPr>
+          <p:cNvPr id="27" name="TextBox 26">
+            <a:extLst>
+              <a:ext uri="{FF2B5EF4-FFF2-40B4-BE49-F238E27FC236}">
+                <a16:creationId xmlns:a16="http://schemas.microsoft.com/office/drawing/2014/main" id="{E81028C4-E25B-7FF4-7512-0D60CB66F0BE}"/>
+              </a:ext>
+            </a:extLst>
+          </p:cNvPr>
+          <p:cNvSpPr txBox="1"/>
+          <p:nvPr/>
+        </p:nvSpPr>
+        <p:spPr>
+          <a:xfrm>
+            <a:off x="8129443" y="6135625"/>
+            <a:ext cx="1307869" cy="320041"/>
+          </a:xfrm>
+          <a:prstGeom prst="rect">
+            <a:avLst/>
+          </a:prstGeom>
+          <a:noFill/>
+        </p:spPr>
+        <p:txBody>
+          <a:bodyPr wrap="square">
+            <a:spAutoFit/>
+          </a:bodyPr>
+          <a:lstStyle/>
+          <a:p>
+            <a:pPr algn="l"/>
+            <a:r>
+              <a:rPr lang="en-US" sz="1500" b="1" i="0" dirty="0" err="1">
+                <a:solidFill>
+                  <a:srgbClr val="2C3E50"/>
+                </a:solidFill>
+                <a:latin typeface="Calibri"/>
+              </a:rPr>
+              <a:t>OpenVLA</a:t>
+            </a:r>
+            <a:endParaRPr sz="1500" b="1" i="0" dirty="0">
+              <a:solidFill>
+                <a:srgbClr val="2C3E50"/>
+              </a:solidFill>
+              <a:latin typeface="Calibri"/>
+            </a:endParaRPr>
           </a:p>
         </p:txBody>
       </p:sp>
@@ -4739,7 +4943,7 @@
 </file>
 
 <file path=ppt/slides/slide12.xml><?xml version="1.0" encoding="utf-8"?>
-<p:sld xmlns:a="http://schemas.openxmlformats.org/drawingml/2006/main" xmlns:p="http://schemas.openxmlformats.org/presentationml/2006/main" xmlns:r="http://schemas.openxmlformats.org/officeDocument/2006/relationships">
+<p:sld xmlns:a="http://schemas.openxmlformats.org/drawingml/2006/main" xmlns:r="http://schemas.openxmlformats.org/officeDocument/2006/relationships" xmlns:p="http://schemas.openxmlformats.org/presentationml/2006/main">
   <p:cSld>
     <p:bg>
       <p:bgPr>
@@ -4755,7 +4959,14 @@
         <p:cNvGrpSpPr/>
         <p:nvPr/>
       </p:nvGrpSpPr>
-      <p:grpSpPr/>
+      <p:grpSpPr>
+        <a:xfrm>
+          <a:off x="0" y="0"/>
+          <a:ext cx="0" cy="0"/>
+          <a:chOff x="0" y="0"/>
+          <a:chExt cx="0" cy="0"/>
+        </a:xfrm>
+      </p:grpSpPr>
       <p:sp>
         <p:nvSpPr>
           <p:cNvPr id="2" name="Rectangle 1"/>
@@ -4796,6 +5007,7 @@
           <a:lstStyle/>
           <a:p>
             <a:pPr algn="ctr"/>
+            <a:endParaRPr/>
           </a:p>
         </p:txBody>
       </p:sp>
@@ -4898,6 +5110,7 @@
           <a:lstStyle/>
           <a:p>
             <a:pPr algn="ctr"/>
+            <a:endParaRPr/>
           </a:p>
         </p:txBody>
       </p:sp>
@@ -5013,6 +5226,7 @@
           <a:lstStyle/>
           <a:p>
             <a:pPr algn="ctr"/>
+            <a:endParaRPr/>
           </a:p>
         </p:txBody>
       </p:sp>
@@ -5129,6 +5343,7 @@
           <a:lstStyle/>
           <a:p>
             <a:pPr algn="ctr"/>
+            <a:endParaRPr/>
           </a:p>
         </p:txBody>
       </p:sp>
@@ -5211,7 +5426,7 @@
 </file>
 
 <file path=ppt/slides/slide13.xml><?xml version="1.0" encoding="utf-8"?>
-<p:sld xmlns:a="http://schemas.openxmlformats.org/drawingml/2006/main" xmlns:p="http://schemas.openxmlformats.org/presentationml/2006/main" xmlns:r="http://schemas.openxmlformats.org/officeDocument/2006/relationships">
+<p:sld xmlns:a="http://schemas.openxmlformats.org/drawingml/2006/main" xmlns:r="http://schemas.openxmlformats.org/officeDocument/2006/relationships" xmlns:p="http://schemas.openxmlformats.org/presentationml/2006/main">
   <p:cSld>
     <p:bg>
       <p:bgPr>
@@ -5227,7 +5442,14 @@
         <p:cNvGrpSpPr/>
         <p:nvPr/>
       </p:nvGrpSpPr>
-      <p:grpSpPr/>
+      <p:grpSpPr>
+        <a:xfrm>
+          <a:off x="0" y="0"/>
+          <a:ext cx="0" cy="0"/>
+          <a:chOff x="0" y="0"/>
+          <a:chExt cx="0" cy="0"/>
+        </a:xfrm>
+      </p:grpSpPr>
       <p:sp>
         <p:nvSpPr>
           <p:cNvPr id="2" name="Rectangle 1"/>
@@ -5268,6 +5490,7 @@
           <a:lstStyle/>
           <a:p>
             <a:pPr algn="ctr"/>
+            <a:endParaRPr/>
           </a:p>
         </p:txBody>
       </p:sp>
@@ -5346,6 +5569,7 @@
           <a:lstStyle/>
           <a:p>
             <a:pPr algn="ctr"/>
+            <a:endParaRPr/>
           </a:p>
         </p:txBody>
       </p:sp>
@@ -5459,6 +5683,7 @@
           <a:lstStyle/>
           <a:p>
             <a:pPr algn="ctr"/>
+            <a:endParaRPr/>
           </a:p>
         </p:txBody>
       </p:sp>
@@ -5534,239 +5759,13 @@
       </p:sp>
       <p:sp>
         <p:nvSpPr>
-          <p:cNvPr id="10" name="Rectangle 9"/>
-          <p:cNvSpPr/>
-          <p:nvPr/>
-        </p:nvSpPr>
-        <p:spPr>
-          <a:xfrm>
-            <a:off x="365760" y="3108960"/>
-            <a:ext cx="2286000" cy="731520"/>
-          </a:xfrm>
-          <a:prstGeom prst="rect">
-            <a:avLst/>
-          </a:prstGeom>
-          <a:solidFill>
-            <a:srgbClr val="E67E22"/>
-          </a:solidFill>
-          <a:ln>
-            <a:noFill/>
-          </a:ln>
-        </p:spPr>
-        <p:style>
-          <a:lnRef idx="1">
-            <a:schemeClr val="accent1"/>
-          </a:lnRef>
-          <a:fillRef idx="3">
-            <a:schemeClr val="accent1"/>
-          </a:fillRef>
-          <a:effectRef idx="2">
-            <a:schemeClr val="accent1"/>
-          </a:effectRef>
-          <a:fontRef idx="minor">
-            <a:schemeClr val="lt1"/>
-          </a:fontRef>
-        </p:style>
-        <p:txBody>
-          <a:bodyPr rtlCol="0" anchor="ctr"/>
-          <a:lstStyle/>
-          <a:p>
-            <a:pPr algn="ctr"/>
-          </a:p>
-        </p:txBody>
-      </p:sp>
-      <p:sp>
-        <p:nvSpPr>
-          <p:cNvPr id="11" name="TextBox 10"/>
-          <p:cNvSpPr txBox="1"/>
-          <p:nvPr/>
-        </p:nvSpPr>
-        <p:spPr>
-          <a:xfrm>
-            <a:off x="457200" y="3200400"/>
-            <a:ext cx="2103120" cy="548640"/>
-          </a:xfrm>
-          <a:prstGeom prst="rect">
-            <a:avLst/>
-          </a:prstGeom>
-          <a:noFill/>
-        </p:spPr>
-        <p:txBody>
-          <a:bodyPr wrap="square">
-            <a:spAutoFit/>
-          </a:bodyPr>
-          <a:lstStyle/>
-          <a:p>
-            <a:pPr algn="l"/>
-            <a:r>
-              <a:rPr sz="1600" b="0" i="0">
-                <a:solidFill>
-                  <a:srgbClr val="FFFFFF"/>
-                </a:solidFill>
-                <a:latin typeface="Calibri"/>
-              </a:rPr>
-              <a:t>2D simulation</a:t>
-            </a:r>
-          </a:p>
-        </p:txBody>
-      </p:sp>
-      <p:sp>
-        <p:nvSpPr>
-          <p:cNvPr id="12" name="TextBox 11"/>
-          <p:cNvSpPr txBox="1"/>
-          <p:nvPr/>
-        </p:nvSpPr>
-        <p:spPr>
-          <a:xfrm>
-            <a:off x="2834640" y="3273552"/>
-            <a:ext cx="8961120" cy="502920"/>
-          </a:xfrm>
-          <a:prstGeom prst="rect">
-            <a:avLst/>
-          </a:prstGeom>
-          <a:noFill/>
-        </p:spPr>
-        <p:txBody>
-          <a:bodyPr wrap="square">
-            <a:spAutoFit/>
-          </a:bodyPr>
-          <a:lstStyle/>
-          <a:p>
-            <a:pPr algn="l"/>
-            <a:r>
-              <a:rPr sz="1500" b="0" i="0">
-                <a:solidFill>
-                  <a:srgbClr val="2C3E50"/>
-                </a:solidFill>
-                <a:latin typeface="Calibri"/>
-              </a:rPr>
-              <a:t>No 3D effects, deformables, or real-robot noise</a:t>
-            </a:r>
-          </a:p>
-        </p:txBody>
-      </p:sp>
-      <p:sp>
-        <p:nvSpPr>
-          <p:cNvPr id="13" name="Rectangle 12"/>
-          <p:cNvSpPr/>
-          <p:nvPr/>
-        </p:nvSpPr>
-        <p:spPr>
-          <a:xfrm>
-            <a:off x="365760" y="3977639"/>
-            <a:ext cx="2286000" cy="731520"/>
-          </a:xfrm>
-          <a:prstGeom prst="rect">
-            <a:avLst/>
-          </a:prstGeom>
-          <a:solidFill>
-            <a:srgbClr val="E67E22"/>
-          </a:solidFill>
-          <a:ln>
-            <a:noFill/>
-          </a:ln>
-        </p:spPr>
-        <p:style>
-          <a:lnRef idx="1">
-            <a:schemeClr val="accent1"/>
-          </a:lnRef>
-          <a:fillRef idx="3">
-            <a:schemeClr val="accent1"/>
-          </a:fillRef>
-          <a:effectRef idx="2">
-            <a:schemeClr val="accent1"/>
-          </a:effectRef>
-          <a:fontRef idx="minor">
-            <a:schemeClr val="lt1"/>
-          </a:fontRef>
-        </p:style>
-        <p:txBody>
-          <a:bodyPr rtlCol="0" anchor="ctr"/>
-          <a:lstStyle/>
-          <a:p>
-            <a:pPr algn="ctr"/>
-          </a:p>
-        </p:txBody>
-      </p:sp>
-      <p:sp>
-        <p:nvSpPr>
-          <p:cNvPr id="14" name="TextBox 13"/>
-          <p:cNvSpPr txBox="1"/>
-          <p:nvPr/>
-        </p:nvSpPr>
-        <p:spPr>
-          <a:xfrm>
-            <a:off x="457200" y="4069079"/>
-            <a:ext cx="2103120" cy="548640"/>
-          </a:xfrm>
-          <a:prstGeom prst="rect">
-            <a:avLst/>
-          </a:prstGeom>
-          <a:noFill/>
-        </p:spPr>
-        <p:txBody>
-          <a:bodyPr wrap="square">
-            <a:spAutoFit/>
-          </a:bodyPr>
-          <a:lstStyle/>
-          <a:p>
-            <a:pPr algn="l"/>
-            <a:r>
-              <a:rPr sz="1600" b="0" i="0">
-                <a:solidFill>
-                  <a:srgbClr val="FFFFFF"/>
-                </a:solidFill>
-                <a:latin typeface="Calibri"/>
-              </a:rPr>
-              <a:t>Policy approx.</a:t>
-            </a:r>
-          </a:p>
-        </p:txBody>
-      </p:sp>
-      <p:sp>
-        <p:nvSpPr>
-          <p:cNvPr id="15" name="TextBox 14"/>
-          <p:cNvSpPr txBox="1"/>
-          <p:nvPr/>
-        </p:nvSpPr>
-        <p:spPr>
-          <a:xfrm>
-            <a:off x="2834640" y="4142231"/>
-            <a:ext cx="8961120" cy="502920"/>
-          </a:xfrm>
-          <a:prstGeom prst="rect">
-            <a:avLst/>
-          </a:prstGeom>
-          <a:noFill/>
-        </p:spPr>
-        <p:txBody>
-          <a:bodyPr wrap="square">
-            <a:spAutoFit/>
-          </a:bodyPr>
-          <a:lstStyle/>
-          <a:p>
-            <a:pPr algn="l"/>
-            <a:r>
-              <a:rPr sz="1500" b="0" i="0">
-                <a:solidFill>
-                  <a:srgbClr val="2C3E50"/>
-                </a:solidFill>
-                <a:latin typeface="Calibri"/>
-              </a:rPr>
-              <a:t>Full GPU OpenVLA inference not integrated</a:t>
-            </a:r>
-          </a:p>
-        </p:txBody>
-      </p:sp>
-      <p:sp>
-        <p:nvSpPr>
           <p:cNvPr id="16" name="Rectangle 15"/>
           <p:cNvSpPr/>
           <p:nvPr/>
         </p:nvSpPr>
         <p:spPr>
           <a:xfrm>
-            <a:off x="365760" y="4846320"/>
+            <a:off x="365760" y="3154680"/>
             <a:ext cx="2286000" cy="731520"/>
           </a:xfrm>
           <a:prstGeom prst="rect">
@@ -5798,6 +5797,7 @@
           <a:lstStyle/>
           <a:p>
             <a:pPr algn="ctr"/>
+            <a:endParaRPr/>
           </a:p>
         </p:txBody>
       </p:sp>
@@ -5809,7 +5809,7 @@
         </p:nvSpPr>
         <p:spPr>
           <a:xfrm>
-            <a:off x="457200" y="4937760"/>
+            <a:off x="457200" y="3246120"/>
             <a:ext cx="2103120" cy="548640"/>
           </a:xfrm>
           <a:prstGeom prst="rect">
@@ -5844,7 +5844,7 @@
         </p:nvSpPr>
         <p:spPr>
           <a:xfrm>
-            <a:off x="2834640" y="5010912"/>
+            <a:off x="2834640" y="3319272"/>
             <a:ext cx="8961120" cy="502920"/>
           </a:xfrm>
           <a:prstGeom prst="rect">
@@ -5879,7 +5879,7 @@
         </p:nvSpPr>
         <p:spPr>
           <a:xfrm>
-            <a:off x="365760" y="5669280"/>
+            <a:off x="365760" y="3977640"/>
             <a:ext cx="11457432" cy="822960"/>
           </a:xfrm>
           <a:prstGeom prst="rect">
@@ -5911,6 +5911,7 @@
           <a:lstStyle/>
           <a:p>
             <a:pPr algn="ctr"/>
+            <a:endParaRPr/>
           </a:p>
         </p:txBody>
       </p:sp>
@@ -5922,7 +5923,7 @@
         </p:nvSpPr>
         <p:spPr>
           <a:xfrm>
-            <a:off x="457200" y="5760720"/>
+            <a:off x="457200" y="4069080"/>
             <a:ext cx="11274552" cy="640080"/>
           </a:xfrm>
           <a:prstGeom prst="rect">
@@ -5989,6 +5990,7 @@
           <a:lstStyle/>
           <a:p>
             <a:pPr algn="ctr"/>
+            <a:endParaRPr/>
           </a:p>
         </p:txBody>
       </p:sp>
@@ -6000,7 +6002,7 @@
         </p:nvSpPr>
         <p:spPr>
           <a:xfrm>
-            <a:off x="182880" y="6592824"/>
+            <a:off x="182880" y="4901184"/>
             <a:ext cx="5486400" cy="228600"/>
           </a:xfrm>
           <a:prstGeom prst="rect">
@@ -6035,7 +6037,7 @@
         </p:nvSpPr>
         <p:spPr>
           <a:xfrm>
-            <a:off x="11091672" y="6592824"/>
+            <a:off x="11091672" y="4901184"/>
             <a:ext cx="914400" cy="228600"/>
           </a:xfrm>
           <a:prstGeom prst="rect">
@@ -6071,7 +6073,7 @@
 </file>
 
 <file path=ppt/slides/slide14.xml><?xml version="1.0" encoding="utf-8"?>
-<p:sld xmlns:a="http://schemas.openxmlformats.org/drawingml/2006/main" xmlns:p="http://schemas.openxmlformats.org/presentationml/2006/main" xmlns:r="http://schemas.openxmlformats.org/officeDocument/2006/relationships">
+<p:sld xmlns:a="http://schemas.openxmlformats.org/drawingml/2006/main" xmlns:r="http://schemas.openxmlformats.org/officeDocument/2006/relationships" xmlns:p="http://schemas.openxmlformats.org/presentationml/2006/main">
   <p:cSld>
     <p:bg>
       <p:bgPr>
@@ -6087,7 +6089,14 @@
         <p:cNvGrpSpPr/>
         <p:nvPr/>
       </p:nvGrpSpPr>
-      <p:grpSpPr/>
+      <p:grpSpPr>
+        <a:xfrm>
+          <a:off x="0" y="0"/>
+          <a:ext cx="0" cy="0"/>
+          <a:chOff x="0" y="0"/>
+          <a:chExt cx="0" cy="0"/>
+        </a:xfrm>
+      </p:grpSpPr>
       <p:sp>
         <p:nvSpPr>
           <p:cNvPr id="2" name="Rectangle 1"/>
@@ -6128,6 +6137,7 @@
           <a:lstStyle/>
           <a:p>
             <a:pPr algn="ctr"/>
+            <a:endParaRPr/>
           </a:p>
         </p:txBody>
       </p:sp>
@@ -6206,6 +6216,7 @@
           <a:lstStyle/>
           <a:p>
             <a:pPr algn="ctr"/>
+            <a:endParaRPr/>
           </a:p>
         </p:txBody>
       </p:sp>
@@ -6285,6 +6296,7 @@
           <a:lstStyle/>
           <a:p>
             <a:pPr algn="ctr"/>
+            <a:endParaRPr/>
           </a:p>
         </p:txBody>
       </p:sp>
@@ -6400,6 +6412,7 @@
           <a:lstStyle/>
           <a:p>
             <a:pPr algn="ctr"/>
+            <a:endParaRPr/>
           </a:p>
         </p:txBody>
       </p:sp>
@@ -6515,6 +6528,7 @@
           <a:lstStyle/>
           <a:p>
             <a:pPr algn="ctr"/>
+            <a:endParaRPr/>
           </a:p>
         </p:txBody>
       </p:sp>
@@ -6700,6 +6714,7 @@
           <a:lstStyle/>
           <a:p>
             <a:pPr algn="ctr"/>
+            <a:endParaRPr/>
           </a:p>
         </p:txBody>
       </p:sp>
@@ -6782,7 +6797,7 @@
 </file>
 
 <file path=ppt/slides/slide2.xml><?xml version="1.0" encoding="utf-8"?>
-<p:sld xmlns:a="http://schemas.openxmlformats.org/drawingml/2006/main" xmlns:p="http://schemas.openxmlformats.org/presentationml/2006/main" xmlns:r="http://schemas.openxmlformats.org/officeDocument/2006/relationships">
+<p:sld xmlns:a="http://schemas.openxmlformats.org/drawingml/2006/main" xmlns:r="http://schemas.openxmlformats.org/officeDocument/2006/relationships" xmlns:p="http://schemas.openxmlformats.org/presentationml/2006/main">
   <p:cSld>
     <p:bg>
       <p:bgPr>
@@ -6798,7 +6813,14 @@
         <p:cNvGrpSpPr/>
         <p:nvPr/>
       </p:nvGrpSpPr>
-      <p:grpSpPr/>
+      <p:grpSpPr>
+        <a:xfrm>
+          <a:off x="0" y="0"/>
+          <a:ext cx="0" cy="0"/>
+          <a:chOff x="0" y="0"/>
+          <a:chExt cx="0" cy="0"/>
+        </a:xfrm>
+      </p:grpSpPr>
       <p:sp>
         <p:nvSpPr>
           <p:cNvPr id="2" name="Rectangle 1"/>
@@ -6839,6 +6861,7 @@
           <a:lstStyle/>
           <a:p>
             <a:pPr algn="ctr"/>
+            <a:endParaRPr/>
           </a:p>
         </p:txBody>
       </p:sp>
@@ -7055,6 +7078,7 @@
           <a:lstStyle/>
           <a:p>
             <a:pPr algn="ctr"/>
+            <a:endParaRPr/>
           </a:p>
         </p:txBody>
       </p:sp>
@@ -7228,6 +7252,7 @@
           <a:lstStyle/>
           <a:p>
             <a:pPr algn="ctr"/>
+            <a:endParaRPr/>
           </a:p>
         </p:txBody>
       </p:sp>
@@ -7310,7 +7335,7 @@
 </file>
 
 <file path=ppt/slides/slide3.xml><?xml version="1.0" encoding="utf-8"?>
-<p:sld xmlns:a="http://schemas.openxmlformats.org/drawingml/2006/main" xmlns:p="http://schemas.openxmlformats.org/presentationml/2006/main" xmlns:r="http://schemas.openxmlformats.org/officeDocument/2006/relationships">
+<p:sld xmlns:a="http://schemas.openxmlformats.org/drawingml/2006/main" xmlns:r="http://schemas.openxmlformats.org/officeDocument/2006/relationships" xmlns:p="http://schemas.openxmlformats.org/presentationml/2006/main">
   <p:cSld>
     <p:bg>
       <p:bgPr>
@@ -7326,7 +7351,14 @@
         <p:cNvGrpSpPr/>
         <p:nvPr/>
       </p:nvGrpSpPr>
-      <p:grpSpPr/>
+      <p:grpSpPr>
+        <a:xfrm>
+          <a:off x="0" y="0"/>
+          <a:ext cx="0" cy="0"/>
+          <a:chOff x="0" y="0"/>
+          <a:chExt cx="0" cy="0"/>
+        </a:xfrm>
+      </p:grpSpPr>
       <p:sp>
         <p:nvSpPr>
           <p:cNvPr id="2" name="Rectangle 1"/>
@@ -7367,6 +7399,7 @@
           <a:lstStyle/>
           <a:p>
             <a:pPr algn="ctr"/>
+            <a:endParaRPr/>
           </a:p>
         </p:txBody>
       </p:sp>
@@ -7445,6 +7478,7 @@
           <a:lstStyle/>
           <a:p>
             <a:pPr algn="ctr"/>
+            <a:endParaRPr/>
           </a:p>
         </p:txBody>
       </p:sp>
@@ -7564,6 +7598,7 @@
           <a:lstStyle/>
           <a:p>
             <a:pPr algn="ctr"/>
+            <a:endParaRPr/>
           </a:p>
         </p:txBody>
       </p:sp>
@@ -7611,7 +7646,7 @@
         <p:spPr>
           <a:xfrm>
             <a:off x="6217920" y="1536192"/>
-            <a:ext cx="5577840" cy="2798064"/>
+            <a:ext cx="5577840" cy="1600438"/>
           </a:xfrm>
           <a:prstGeom prst="rect">
             <a:avLst/>
@@ -7626,14 +7661,22 @@
           <a:p>
             <a:pPr algn="l"/>
             <a:r>
-              <a:rPr sz="1400" b="0" i="0">
+              <a:rPr sz="1400" b="0" i="0" dirty="0" err="1">
                 <a:solidFill>
                   <a:srgbClr val="FFFFFF"/>
                 </a:solidFill>
                 <a:latin typeface="Calibri"/>
               </a:rPr>
-              <a:t>PhysCoT (ours):
-✅  No training — pure inference-time prompting
+              <a:t>PhysCoT</a:t>
+            </a:r>
+            <a:r>
+              <a:rPr sz="1400" b="0" i="0" dirty="0">
+                <a:solidFill>
+                  <a:srgbClr val="FFFFFF"/>
+                </a:solidFill>
+                <a:latin typeface="Calibri"/>
+              </a:rPr>
+              <a:t> (ours):
 ✅  Explicitly physics-aware reasoning:
      Torque, friction, stability, tool affordance
 ✅  Visually grounded physical estimates
@@ -7718,6 +7761,7 @@
           <a:lstStyle/>
           <a:p>
             <a:pPr algn="ctr"/>
+            <a:endParaRPr/>
           </a:p>
         </p:txBody>
       </p:sp>
@@ -7796,6 +7840,7 @@
           <a:lstStyle/>
           <a:p>
             <a:pPr algn="ctr"/>
+            <a:endParaRPr/>
           </a:p>
         </p:txBody>
       </p:sp>
@@ -7878,7 +7923,7 @@
 </file>
 
 <file path=ppt/slides/slide4.xml><?xml version="1.0" encoding="utf-8"?>
-<p:sld xmlns:a="http://schemas.openxmlformats.org/drawingml/2006/main" xmlns:p="http://schemas.openxmlformats.org/presentationml/2006/main" xmlns:r="http://schemas.openxmlformats.org/officeDocument/2006/relationships">
+<p:sld xmlns:a="http://schemas.openxmlformats.org/drawingml/2006/main" xmlns:r="http://schemas.openxmlformats.org/officeDocument/2006/relationships" xmlns:p="http://schemas.openxmlformats.org/presentationml/2006/main">
   <p:cSld>
     <p:bg>
       <p:bgPr>
@@ -7894,7 +7939,14 @@
         <p:cNvGrpSpPr/>
         <p:nvPr/>
       </p:nvGrpSpPr>
-      <p:grpSpPr/>
+      <p:grpSpPr>
+        <a:xfrm>
+          <a:off x="0" y="0"/>
+          <a:ext cx="0" cy="0"/>
+          <a:chOff x="0" y="0"/>
+          <a:chExt cx="0" cy="0"/>
+        </a:xfrm>
+      </p:grpSpPr>
       <p:sp>
         <p:nvSpPr>
           <p:cNvPr id="2" name="Rectangle 1"/>
@@ -7935,6 +7987,7 @@
           <a:lstStyle/>
           <a:p>
             <a:pPr algn="ctr"/>
+            <a:endParaRPr/>
           </a:p>
         </p:txBody>
       </p:sp>
@@ -8013,6 +8066,7 @@
           <a:lstStyle/>
           <a:p>
             <a:pPr algn="ctr"/>
+            <a:endParaRPr/>
           </a:p>
         </p:txBody>
       </p:sp>
@@ -8091,6 +8145,7 @@
           <a:lstStyle/>
           <a:p>
             <a:pPr algn="ctr"/>
+            <a:endParaRPr/>
           </a:p>
         </p:txBody>
       </p:sp>
@@ -8170,6 +8225,7 @@
           <a:lstStyle/>
           <a:p>
             <a:pPr algn="ctr"/>
+            <a:endParaRPr/>
           </a:p>
         </p:txBody>
       </p:sp>
@@ -8285,6 +8341,7 @@
           <a:lstStyle/>
           <a:p>
             <a:pPr algn="ctr"/>
+            <a:endParaRPr/>
           </a:p>
         </p:txBody>
       </p:sp>
@@ -8363,6 +8420,7 @@
           <a:lstStyle/>
           <a:p>
             <a:pPr algn="ctr"/>
+            <a:endParaRPr/>
           </a:p>
         </p:txBody>
       </p:sp>
@@ -8442,6 +8500,7 @@
           <a:lstStyle/>
           <a:p>
             <a:pPr algn="ctr"/>
+            <a:endParaRPr/>
           </a:p>
         </p:txBody>
       </p:sp>
@@ -8557,6 +8616,7 @@
           <a:lstStyle/>
           <a:p>
             <a:pPr algn="ctr"/>
+            <a:endParaRPr/>
           </a:p>
         </p:txBody>
       </p:sp>
@@ -8635,6 +8695,7 @@
           <a:lstStyle/>
           <a:p>
             <a:pPr algn="ctr"/>
+            <a:endParaRPr/>
           </a:p>
         </p:txBody>
       </p:sp>
@@ -8714,6 +8775,7 @@
           <a:lstStyle/>
           <a:p>
             <a:pPr algn="ctr"/>
+            <a:endParaRPr/>
           </a:p>
         </p:txBody>
       </p:sp>
@@ -8829,6 +8891,7 @@
           <a:lstStyle/>
           <a:p>
             <a:pPr algn="ctr"/>
+            <a:endParaRPr/>
           </a:p>
         </p:txBody>
       </p:sp>
@@ -8907,6 +8970,7 @@
           <a:lstStyle/>
           <a:p>
             <a:pPr algn="ctr"/>
+            <a:endParaRPr/>
           </a:p>
         </p:txBody>
       </p:sp>
@@ -8986,6 +9050,7 @@
           <a:lstStyle/>
           <a:p>
             <a:pPr algn="ctr"/>
+            <a:endParaRPr/>
           </a:p>
         </p:txBody>
       </p:sp>
@@ -9066,6 +9131,7 @@
           <a:lstStyle/>
           <a:p>
             <a:pPr algn="ctr"/>
+            <a:endParaRPr/>
           </a:p>
         </p:txBody>
       </p:sp>
@@ -9145,6 +9211,7 @@
           <a:lstStyle/>
           <a:p>
             <a:pPr algn="ctr"/>
+            <a:endParaRPr/>
           </a:p>
         </p:txBody>
       </p:sp>
@@ -9227,7 +9294,7 @@
 </file>
 
 <file path=ppt/slides/slide5.xml><?xml version="1.0" encoding="utf-8"?>
-<p:sld xmlns:a="http://schemas.openxmlformats.org/drawingml/2006/main" xmlns:p="http://schemas.openxmlformats.org/presentationml/2006/main" xmlns:r="http://schemas.openxmlformats.org/officeDocument/2006/relationships">
+<p:sld xmlns:a="http://schemas.openxmlformats.org/drawingml/2006/main" xmlns:r="http://schemas.openxmlformats.org/officeDocument/2006/relationships" xmlns:p="http://schemas.openxmlformats.org/presentationml/2006/main">
   <p:cSld>
     <p:bg>
       <p:bgPr>
@@ -9243,7 +9310,14 @@
         <p:cNvGrpSpPr/>
         <p:nvPr/>
       </p:nvGrpSpPr>
-      <p:grpSpPr/>
+      <p:grpSpPr>
+        <a:xfrm>
+          <a:off x="0" y="0"/>
+          <a:ext cx="0" cy="0"/>
+          <a:chOff x="0" y="0"/>
+          <a:chExt cx="0" cy="0"/>
+        </a:xfrm>
+      </p:grpSpPr>
       <p:sp>
         <p:nvSpPr>
           <p:cNvPr id="2" name="Rectangle 1"/>
@@ -9284,6 +9358,7 @@
           <a:lstStyle/>
           <a:p>
             <a:pPr algn="ctr"/>
+            <a:endParaRPr/>
           </a:p>
         </p:txBody>
       </p:sp>
@@ -9457,6 +9532,7 @@
           <a:lstStyle/>
           <a:p>
             <a:pPr algn="ctr"/>
+            <a:endParaRPr/>
           </a:p>
         </p:txBody>
       </p:sp>
@@ -9539,7 +9615,7 @@
 </file>
 
 <file path=ppt/slides/slide6.xml><?xml version="1.0" encoding="utf-8"?>
-<p:sld xmlns:a="http://schemas.openxmlformats.org/drawingml/2006/main" xmlns:p="http://schemas.openxmlformats.org/presentationml/2006/main" xmlns:r="http://schemas.openxmlformats.org/officeDocument/2006/relationships">
+<p:sld xmlns:a="http://schemas.openxmlformats.org/drawingml/2006/main" xmlns:r="http://schemas.openxmlformats.org/officeDocument/2006/relationships" xmlns:p="http://schemas.openxmlformats.org/presentationml/2006/main">
   <p:cSld>
     <p:bg>
       <p:bgPr>
@@ -9555,7 +9631,14 @@
         <p:cNvGrpSpPr/>
         <p:nvPr/>
       </p:nvGrpSpPr>
-      <p:grpSpPr/>
+      <p:grpSpPr>
+        <a:xfrm>
+          <a:off x="0" y="0"/>
+          <a:ext cx="0" cy="0"/>
+          <a:chOff x="0" y="0"/>
+          <a:chExt cx="0" cy="0"/>
+        </a:xfrm>
+      </p:grpSpPr>
       <p:sp>
         <p:nvSpPr>
           <p:cNvPr id="2" name="Rectangle 1"/>
@@ -9596,6 +9679,7 @@
           <a:lstStyle/>
           <a:p>
             <a:pPr algn="ctr"/>
+            <a:endParaRPr/>
           </a:p>
         </p:txBody>
       </p:sp>
@@ -9709,6 +9793,7 @@
           <a:lstStyle/>
           <a:p>
             <a:pPr algn="ctr"/>
+            <a:endParaRPr/>
           </a:p>
         </p:txBody>
       </p:sp>
@@ -9919,6 +10004,7 @@
           <a:lstStyle/>
           <a:p>
             <a:pPr algn="ctr"/>
+            <a:endParaRPr/>
           </a:p>
         </p:txBody>
       </p:sp>
@@ -10001,7 +10087,7 @@
 </file>
 
 <file path=ppt/slides/slide7.xml><?xml version="1.0" encoding="utf-8"?>
-<p:sld xmlns:a="http://schemas.openxmlformats.org/drawingml/2006/main" xmlns:p="http://schemas.openxmlformats.org/presentationml/2006/main" xmlns:r="http://schemas.openxmlformats.org/officeDocument/2006/relationships">
+<p:sld xmlns:a="http://schemas.openxmlformats.org/drawingml/2006/main" xmlns:r="http://schemas.openxmlformats.org/officeDocument/2006/relationships" xmlns:p="http://schemas.openxmlformats.org/presentationml/2006/main">
   <p:cSld>
     <p:bg>
       <p:bgPr>
@@ -10017,7 +10103,14 @@
         <p:cNvGrpSpPr/>
         <p:nvPr/>
       </p:nvGrpSpPr>
-      <p:grpSpPr/>
+      <p:grpSpPr>
+        <a:xfrm>
+          <a:off x="0" y="0"/>
+          <a:ext cx="0" cy="0"/>
+          <a:chOff x="0" y="0"/>
+          <a:chExt cx="0" cy="0"/>
+        </a:xfrm>
+      </p:grpSpPr>
       <p:sp>
         <p:nvSpPr>
           <p:cNvPr id="2" name="Rectangle 1"/>
@@ -10058,6 +10151,7 @@
           <a:lstStyle/>
           <a:p>
             <a:pPr algn="ctr"/>
+            <a:endParaRPr/>
           </a:p>
         </p:txBody>
       </p:sp>
@@ -10171,6 +10265,7 @@
           <a:lstStyle/>
           <a:p>
             <a:pPr algn="ctr"/>
+            <a:endParaRPr/>
           </a:p>
         </p:txBody>
       </p:sp>
@@ -10287,6 +10382,7 @@
           <a:lstStyle/>
           <a:p>
             <a:pPr algn="ctr"/>
+            <a:endParaRPr/>
           </a:p>
         </p:txBody>
       </p:sp>
@@ -10403,6 +10499,7 @@
           <a:lstStyle/>
           <a:p>
             <a:pPr algn="ctr"/>
+            <a:endParaRPr/>
           </a:p>
         </p:txBody>
       </p:sp>
@@ -10576,6 +10673,7 @@
           <a:lstStyle/>
           <a:p>
             <a:pPr algn="ctr"/>
+            <a:endParaRPr/>
           </a:p>
         </p:txBody>
       </p:sp>
@@ -10658,7 +10756,7 @@
 </file>
 
 <file path=ppt/slides/slide8.xml><?xml version="1.0" encoding="utf-8"?>
-<p:sld xmlns:a="http://schemas.openxmlformats.org/drawingml/2006/main" xmlns:p="http://schemas.openxmlformats.org/presentationml/2006/main" xmlns:r="http://schemas.openxmlformats.org/officeDocument/2006/relationships">
+<p:sld xmlns:a="http://schemas.openxmlformats.org/drawingml/2006/main" xmlns:r="http://schemas.openxmlformats.org/officeDocument/2006/relationships" xmlns:p="http://schemas.openxmlformats.org/presentationml/2006/main">
   <p:cSld>
     <p:bg>
       <p:bgPr>
@@ -10674,7 +10772,14 @@
         <p:cNvGrpSpPr/>
         <p:nvPr/>
       </p:nvGrpSpPr>
-      <p:grpSpPr/>
+      <p:grpSpPr>
+        <a:xfrm>
+          <a:off x="0" y="0"/>
+          <a:ext cx="0" cy="0"/>
+          <a:chOff x="0" y="0"/>
+          <a:chExt cx="0" cy="0"/>
+        </a:xfrm>
+      </p:grpSpPr>
       <p:sp>
         <p:nvSpPr>
           <p:cNvPr id="2" name="Rectangle 1"/>
@@ -10715,6 +10820,7 @@
           <a:lstStyle/>
           <a:p>
             <a:pPr algn="ctr"/>
+            <a:endParaRPr/>
           </a:p>
         </p:txBody>
       </p:sp>
@@ -10819,6 +10925,7 @@
           <a:lstStyle/>
           <a:p>
             <a:pPr algn="ctr"/>
+            <a:endParaRPr/>
           </a:p>
         </p:txBody>
       </p:sp>
@@ -10969,6 +11076,7 @@
           <a:lstStyle/>
           <a:p>
             <a:pPr algn="ctr"/>
+            <a:endParaRPr/>
           </a:p>
         </p:txBody>
       </p:sp>
@@ -11119,6 +11227,7 @@
           <a:lstStyle/>
           <a:p>
             <a:pPr algn="ctr"/>
+            <a:endParaRPr/>
           </a:p>
         </p:txBody>
       </p:sp>
@@ -11145,15 +11254,7 @@
           <a:lstStyle/>
           <a:p>
             <a:pPr algn="l"/>
-            <a:r>
-              <a:rPr sz="1200" b="0" i="0">
-                <a:solidFill>
-                  <a:srgbClr val="FFFFFF"/>
-                </a:solidFill>
-                <a:latin typeface="Calibri"/>
-              </a:rPr>
-              <a:t/>
-            </a:r>
+            <a:endParaRPr/>
           </a:p>
         </p:txBody>
       </p:sp>
@@ -11269,6 +11370,7 @@
           <a:lstStyle/>
           <a:p>
             <a:pPr algn="ctr"/>
+            <a:endParaRPr/>
           </a:p>
         </p:txBody>
       </p:sp>
@@ -11419,6 +11521,7 @@
           <a:lstStyle/>
           <a:p>
             <a:pPr algn="ctr"/>
+            <a:endParaRPr/>
           </a:p>
         </p:txBody>
       </p:sp>
@@ -11569,6 +11672,7 @@
           <a:lstStyle/>
           <a:p>
             <a:pPr algn="ctr"/>
+            <a:endParaRPr/>
           </a:p>
         </p:txBody>
       </p:sp>
@@ -11595,15 +11699,7 @@
           <a:lstStyle/>
           <a:p>
             <a:pPr algn="l"/>
-            <a:r>
-              <a:rPr sz="1200" b="0" i="0">
-                <a:solidFill>
-                  <a:srgbClr val="FFFFFF"/>
-                </a:solidFill>
-                <a:latin typeface="Calibri"/>
-              </a:rPr>
-              <a:t/>
-            </a:r>
+            <a:endParaRPr/>
           </a:p>
         </p:txBody>
       </p:sp>
@@ -11752,6 +11848,7 @@
           <a:lstStyle/>
           <a:p>
             <a:pPr algn="ctr"/>
+            <a:endParaRPr/>
           </a:p>
         </p:txBody>
       </p:sp>
@@ -11834,7 +11931,7 @@
 </file>
 
 <file path=ppt/slides/slide9.xml><?xml version="1.0" encoding="utf-8"?>
-<p:sld xmlns:a="http://schemas.openxmlformats.org/drawingml/2006/main" xmlns:p="http://schemas.openxmlformats.org/presentationml/2006/main" xmlns:r="http://schemas.openxmlformats.org/officeDocument/2006/relationships">
+<p:sld xmlns:a="http://schemas.openxmlformats.org/drawingml/2006/main" xmlns:r="http://schemas.openxmlformats.org/officeDocument/2006/relationships" xmlns:p="http://schemas.openxmlformats.org/presentationml/2006/main">
   <p:cSld>
     <p:bg>
       <p:bgPr>
@@ -11850,7 +11947,14 @@
         <p:cNvGrpSpPr/>
         <p:nvPr/>
       </p:nvGrpSpPr>
-      <p:grpSpPr/>
+      <p:grpSpPr>
+        <a:xfrm>
+          <a:off x="0" y="0"/>
+          <a:ext cx="0" cy="0"/>
+          <a:chOff x="0" y="0"/>
+          <a:chExt cx="0" cy="0"/>
+        </a:xfrm>
+      </p:grpSpPr>
       <p:sp>
         <p:nvSpPr>
           <p:cNvPr id="2" name="Rectangle 1"/>
@@ -11891,6 +11995,7 @@
           <a:lstStyle/>
           <a:p>
             <a:pPr algn="ctr"/>
+            <a:endParaRPr/>
           </a:p>
         </p:txBody>
       </p:sp>
@@ -12063,6 +12168,7 @@
           <a:lstStyle/>
           <a:p>
             <a:pPr algn="ctr"/>
+            <a:endParaRPr/>
           </a:p>
         </p:txBody>
       </p:sp>

</xml_diff>